<commit_message>
Update SEFOP Informs Annual Meeting 2026.pptx
</commit_message>
<xml_diff>
--- a/workshops/2026-11-01-informs-annual-meeting/SEFOP Informs Annual Meeting 2026.pptx
+++ b/workshops/2026-11-01-informs-annual-meeting/SEFOP Informs Annual Meeting 2026.pptx
@@ -13,8 +13,8 @@
     <p:sldId id="268" r:id="rId4"/>
     <p:sldId id="273" r:id="rId5"/>
     <p:sldId id="277" r:id="rId6"/>
-    <p:sldId id="274" r:id="rId7"/>
-    <p:sldId id="280" r:id="rId8"/>
+    <p:sldId id="280" r:id="rId7"/>
+    <p:sldId id="281" r:id="rId8"/>
     <p:sldId id="272" r:id="rId9"/>
     <p:sldId id="279" r:id="rId10"/>
   </p:sldIdLst>
@@ -216,7 +216,7 @@
           <a:p>
             <a:fld id="{A9508B69-4B04-442E-A249-3DCED873EEFA}" type="datetimeFigureOut">
               <a:rPr lang="en-US" smtClean="0"/>
-              <a:t>10/28/2026</a:t>
+              <a:t>10/30/2026</a:t>
             </a:fld>
             <a:endParaRPr lang="en-US"/>
           </a:p>
@@ -855,6 +855,22 @@
               <a:t>SEFOP exists so OR teams do not have to rediscover these practices independently.</a:t>
             </a:r>
           </a:p>
+          <a:p>
+            <a:pPr algn="l">
+              <a:spcAft>
+                <a:spcPts val="400"/>
+              </a:spcAft>
+            </a:pPr>
+            <a:r>
+              <a:rPr lang="en-US" sz="1200" b="0" dirty="0">
+                <a:solidFill>
+                  <a:srgbClr val="64748B"/>
+                </a:solidFill>
+                <a:latin typeface="+mn-lt"/>
+              </a:rPr>
+              <a:t>Hook: example testing a DSS</a:t>
+            </a:r>
+          </a:p>
         </p:txBody>
       </p:sp>
       <p:sp>
@@ -878,78 +894,6 @@
 </file>
 
 <file path=ppt/notesSlides/notesSlide6.xml><?xml version="1.0" encoding="utf-8"?>
-<p:notes xmlns:a="http://schemas.openxmlformats.org/drawingml/2006/main" xmlns:r="http://schemas.openxmlformats.org/officeDocument/2006/relationships" xmlns:p="http://schemas.openxmlformats.org/presentationml/2006/main">
-  <p:cSld>
-    <p:spTree>
-      <p:nvGrpSpPr>
-        <p:cNvPr id="1" name=""/>
-        <p:cNvGrpSpPr/>
-        <p:nvPr/>
-      </p:nvGrpSpPr>
-      <p:grpSpPr>
-        <a:xfrm>
-          <a:off x="0" y="0"/>
-          <a:ext cx="0" cy="0"/>
-          <a:chOff x="0" y="0"/>
-          <a:chExt cx="0" cy="0"/>
-        </a:xfrm>
-      </p:grpSpPr>
-      <p:sp>
-        <p:nvSpPr>
-          <p:cNvPr id="2" name="Slide Image Placeholder 1"/>
-          <p:cNvSpPr>
-            <a:spLocks noGrp="1" noRot="1" noChangeAspect="1"/>
-          </p:cNvSpPr>
-          <p:nvPr>
-            <p:ph type="sldImg" idx="2"/>
-          </p:nvPr>
-        </p:nvSpPr>
-        <p:spPr/>
-      </p:sp>
-      <p:sp>
-        <p:nvSpPr>
-          <p:cNvPr id="3" name="Notes Placeholder 2"/>
-          <p:cNvSpPr>
-            <a:spLocks noGrp="1"/>
-          </p:cNvSpPr>
-          <p:nvPr>
-            <p:ph type="body" sz="quarter" idx="3"/>
-          </p:nvPr>
-        </p:nvSpPr>
-        <p:spPr/>
-        <p:txBody>
-          <a:bodyPr/>
-          <a:lstStyle/>
-          <a:p>
-            <a:r>
-              <a:rPr lang="en-US" dirty="0"/>
-              <a:t>Hook:</a:t>
-            </a:r>
-            <a:endParaRPr dirty="0"/>
-          </a:p>
-        </p:txBody>
-      </p:sp>
-      <p:sp>
-        <p:nvSpPr>
-          <p:cNvPr id="4" name="Slide Number Placeholder 3"/>
-          <p:cNvSpPr>
-            <a:spLocks noGrp="1"/>
-          </p:cNvSpPr>
-          <p:nvPr>
-            <p:ph type="sldNum" sz="quarter" idx="5"/>
-          </p:nvPr>
-        </p:nvSpPr>
-        <p:spPr/>
-      </p:sp>
-    </p:spTree>
-  </p:cSld>
-  <p:clrMapOvr>
-    <a:masterClrMapping/>
-  </p:clrMapOvr>
-</p:notes>
-</file>
-
-<file path=ppt/notesSlides/notesSlide7.xml><?xml version="1.0" encoding="utf-8"?>
 <p:notes xmlns:a="http://schemas.openxmlformats.org/drawingml/2006/main" xmlns:r="http://schemas.openxmlformats.org/officeDocument/2006/relationships" xmlns:p="http://schemas.openxmlformats.org/presentationml/2006/main">
   <p:cSld>
     <p:spTree>
@@ -1011,10 +955,6 @@
           <a:bodyPr/>
           <a:lstStyle/>
           <a:p>
-            <a:r>
-              <a:rPr lang="en-US" dirty="0"/>
-              <a:t>Hook:</a:t>
-            </a:r>
             <a:endParaRPr dirty="0"/>
           </a:p>
         </p:txBody>
@@ -1041,6 +981,103 @@
     <p:extLst>
       <p:ext uri="{BB962C8B-B14F-4D97-AF65-F5344CB8AC3E}">
         <p14:creationId xmlns:p14="http://schemas.microsoft.com/office/powerpoint/2010/main" val="386423108"/>
+      </p:ext>
+    </p:extLst>
+  </p:cSld>
+  <p:clrMapOvr>
+    <a:masterClrMapping/>
+  </p:clrMapOvr>
+</p:notes>
+</file>
+
+<file path=ppt/notesSlides/notesSlide7.xml><?xml version="1.0" encoding="utf-8"?>
+<p:notes xmlns:a="http://schemas.openxmlformats.org/drawingml/2006/main" xmlns:r="http://schemas.openxmlformats.org/officeDocument/2006/relationships" xmlns:p="http://schemas.openxmlformats.org/presentationml/2006/main">
+  <p:cSld>
+    <p:spTree>
+      <p:nvGrpSpPr>
+        <p:cNvPr id="1" name="">
+          <a:extLst>
+            <a:ext uri="{FF2B5EF4-FFF2-40B4-BE49-F238E27FC236}">
+              <a16:creationId xmlns:a16="http://schemas.microsoft.com/office/drawing/2014/main" id="{B360F9ED-F334-24E6-97F6-3D58D0FA579F}"/>
+            </a:ext>
+          </a:extLst>
+        </p:cNvPr>
+        <p:cNvGrpSpPr/>
+        <p:nvPr/>
+      </p:nvGrpSpPr>
+      <p:grpSpPr>
+        <a:xfrm>
+          <a:off x="0" y="0"/>
+          <a:ext cx="0" cy="0"/>
+          <a:chOff x="0" y="0"/>
+          <a:chExt cx="0" cy="0"/>
+        </a:xfrm>
+      </p:grpSpPr>
+      <p:sp>
+        <p:nvSpPr>
+          <p:cNvPr id="2" name="Slide Image Placeholder 1">
+            <a:extLst>
+              <a:ext uri="{FF2B5EF4-FFF2-40B4-BE49-F238E27FC236}">
+                <a16:creationId xmlns:a16="http://schemas.microsoft.com/office/drawing/2014/main" id="{62D35857-4435-1C0C-5DBF-0ED9ECE4F807}"/>
+              </a:ext>
+            </a:extLst>
+          </p:cNvPr>
+          <p:cNvSpPr>
+            <a:spLocks noGrp="1" noRot="1" noChangeAspect="1"/>
+          </p:cNvSpPr>
+          <p:nvPr>
+            <p:ph type="sldImg" idx="2"/>
+          </p:nvPr>
+        </p:nvSpPr>
+        <p:spPr/>
+      </p:sp>
+      <p:sp>
+        <p:nvSpPr>
+          <p:cNvPr id="3" name="Notes Placeholder 2">
+            <a:extLst>
+              <a:ext uri="{FF2B5EF4-FFF2-40B4-BE49-F238E27FC236}">
+                <a16:creationId xmlns:a16="http://schemas.microsoft.com/office/drawing/2014/main" id="{C0D14A93-FF7A-DAC5-3667-66A8DA8C683C}"/>
+              </a:ext>
+            </a:extLst>
+          </p:cNvPr>
+          <p:cNvSpPr>
+            <a:spLocks noGrp="1"/>
+          </p:cNvSpPr>
+          <p:nvPr>
+            <p:ph type="body" sz="quarter" idx="3"/>
+          </p:nvPr>
+        </p:nvSpPr>
+        <p:spPr/>
+        <p:txBody>
+          <a:bodyPr/>
+          <a:lstStyle/>
+          <a:p>
+            <a:endParaRPr dirty="0"/>
+          </a:p>
+        </p:txBody>
+      </p:sp>
+      <p:sp>
+        <p:nvSpPr>
+          <p:cNvPr id="4" name="Slide Number Placeholder 3">
+            <a:extLst>
+              <a:ext uri="{FF2B5EF4-FFF2-40B4-BE49-F238E27FC236}">
+                <a16:creationId xmlns:a16="http://schemas.microsoft.com/office/drawing/2014/main" id="{FDD869E8-5CEB-C1C3-DD4B-368F0ADEA124}"/>
+              </a:ext>
+            </a:extLst>
+          </p:cNvPr>
+          <p:cNvSpPr>
+            <a:spLocks noGrp="1"/>
+          </p:cNvSpPr>
+          <p:nvPr>
+            <p:ph type="sldNum" sz="quarter" idx="5"/>
+          </p:nvPr>
+        </p:nvSpPr>
+        <p:spPr/>
+      </p:sp>
+    </p:spTree>
+    <p:extLst>
+      <p:ext uri="{BB962C8B-B14F-4D97-AF65-F5344CB8AC3E}">
+        <p14:creationId xmlns:p14="http://schemas.microsoft.com/office/powerpoint/2010/main" val="1982042349"/>
       </p:ext>
     </p:extLst>
   </p:cSld>
@@ -1451,7 +1488,7 @@
           <a:p>
             <a:fld id="{8967FF14-F878-45E8-AFB4-46D953F41C81}" type="datetime1">
               <a:rPr lang="en-US" smtClean="0"/>
-              <a:t>10/28/2026</a:t>
+              <a:t>10/30/2026</a:t>
             </a:fld>
             <a:endParaRPr lang="en-US"/>
           </a:p>
@@ -1619,7 +1656,7 @@
           <a:p>
             <a:fld id="{44869591-628F-4BAB-AD9F-697EBD829841}" type="datetime1">
               <a:rPr lang="en-US" smtClean="0"/>
-              <a:t>10/28/2026</a:t>
+              <a:t>10/30/2026</a:t>
             </a:fld>
             <a:endParaRPr lang="en-US"/>
           </a:p>
@@ -1797,7 +1834,7 @@
           <a:p>
             <a:fld id="{76AEFADA-DB7A-4DBF-B5C8-201C4683F8E6}" type="datetime1">
               <a:rPr lang="en-US" smtClean="0"/>
-              <a:t>10/28/2026</a:t>
+              <a:t>10/30/2026</a:t>
             </a:fld>
             <a:endParaRPr lang="en-US"/>
           </a:p>
@@ -1965,7 +2002,7 @@
           <a:p>
             <a:fld id="{BE3B6F46-0C3C-4175-8B43-348544656D81}" type="datetime1">
               <a:rPr lang="en-US" smtClean="0"/>
-              <a:t>10/28/2026</a:t>
+              <a:t>10/30/2026</a:t>
             </a:fld>
             <a:endParaRPr lang="en-US"/>
           </a:p>
@@ -2210,7 +2247,7 @@
           <a:p>
             <a:fld id="{AA346EC6-7322-4DBC-84C7-E11D30942555}" type="datetime1">
               <a:rPr lang="en-US" smtClean="0"/>
-              <a:t>10/28/2026</a:t>
+              <a:t>10/30/2026</a:t>
             </a:fld>
             <a:endParaRPr lang="en-US"/>
           </a:p>
@@ -2495,7 +2532,7 @@
           <a:p>
             <a:fld id="{22848B31-6056-4B86-B43A-9DBD0BACB6B8}" type="datetime1">
               <a:rPr lang="en-US" smtClean="0"/>
-              <a:t>10/28/2026</a:t>
+              <a:t>10/30/2026</a:t>
             </a:fld>
             <a:endParaRPr lang="en-US"/>
           </a:p>
@@ -2914,7 +2951,7 @@
           <a:p>
             <a:fld id="{5E9A4DAE-E39A-4AB4-9A37-8C4CE854B5ED}" type="datetime1">
               <a:rPr lang="en-US" smtClean="0"/>
-              <a:t>10/28/2026</a:t>
+              <a:t>10/30/2026</a:t>
             </a:fld>
             <a:endParaRPr lang="en-US"/>
           </a:p>
@@ -3031,7 +3068,7 @@
           <a:p>
             <a:fld id="{CCC0320F-0C3E-448D-9224-8CF88A1B4ED1}" type="datetime1">
               <a:rPr lang="en-US" smtClean="0"/>
-              <a:t>10/28/2026</a:t>
+              <a:t>10/30/2026</a:t>
             </a:fld>
             <a:endParaRPr lang="en-US"/>
           </a:p>
@@ -3126,7 +3163,7 @@
           <a:p>
             <a:fld id="{A2C46C6B-8CC5-4835-9317-0254AF58E7FA}" type="datetime1">
               <a:rPr lang="en-US" smtClean="0"/>
-              <a:t>10/28/2026</a:t>
+              <a:t>10/30/2026</a:t>
             </a:fld>
             <a:endParaRPr lang="en-US"/>
           </a:p>
@@ -3406,7 +3443,7 @@
           <a:p>
             <a:fld id="{AC12DB2F-C7F6-4FDA-BA62-32815EE05B27}" type="datetime1">
               <a:rPr lang="en-US" smtClean="0"/>
-              <a:t>10/28/2026</a:t>
+              <a:t>10/30/2026</a:t>
             </a:fld>
             <a:endParaRPr lang="en-US"/>
           </a:p>
@@ -3658,7 +3695,7 @@
           <a:p>
             <a:fld id="{5A7BFFA9-8A0F-4C1F-BDA9-E4A846D0523F}" type="datetime1">
               <a:rPr lang="en-US" smtClean="0"/>
-              <a:t>10/28/2026</a:t>
+              <a:t>10/30/2026</a:t>
             </a:fld>
             <a:endParaRPr lang="en-US"/>
           </a:p>
@@ -3869,7 +3906,7 @@
           <a:p>
             <a:fld id="{AE506CE3-984D-4D4B-A976-00BBA5D668A5}" type="datetime1">
               <a:rPr lang="en-US" smtClean="0"/>
-              <a:t>10/28/2026</a:t>
+              <a:t>10/30/2026</a:t>
             </a:fld>
             <a:endParaRPr lang="en-US"/>
           </a:p>
@@ -7862,7 +7899,7 @@
                 </a:solidFill>
                 <a:latin typeface="Aptos Display"/>
               </a:rPr>
-              <a:t>AI-coding assistants require the engineering foundations: they </a:t>
+              <a:t>AI-coding assistants require strong engineering foundations: they </a:t>
             </a:r>
             <a:r>
               <a:rPr lang="en-US" sz="4000" b="1" dirty="0">
@@ -10121,7 +10158,7 @@
         <p:cNvPr id="1" name="">
           <a:extLst>
             <a:ext uri="{FF2B5EF4-FFF2-40B4-BE49-F238E27FC236}">
-              <a16:creationId xmlns:a16="http://schemas.microsoft.com/office/drawing/2014/main" id="{9C7ECAD1-18DD-1E1E-6665-6526783BB1D4}"/>
+              <a16:creationId xmlns:a16="http://schemas.microsoft.com/office/drawing/2014/main" id="{F0943D2B-3609-E5F2-359E-009AD3775975}"/>
             </a:ext>
           </a:extLst>
         </p:cNvPr>
@@ -10141,7 +10178,7 @@
           <p:cNvPr id="2" name="TextBox 1">
             <a:extLst>
               <a:ext uri="{FF2B5EF4-FFF2-40B4-BE49-F238E27FC236}">
-                <a16:creationId xmlns:a16="http://schemas.microsoft.com/office/drawing/2014/main" id="{E7DE0521-074C-088B-6C50-531DDADE8C94}"/>
+                <a16:creationId xmlns:a16="http://schemas.microsoft.com/office/drawing/2014/main" id="{8ADACEFF-A6FF-EB27-D151-97B21A72ED1E}"/>
               </a:ext>
             </a:extLst>
           </p:cNvPr>
@@ -10151,7 +10188,7 @@
         <p:spPr>
           <a:xfrm>
             <a:off x="365760" y="213360"/>
-            <a:ext cx="11567160" cy="615553"/>
+            <a:ext cx="11826240" cy="1231106"/>
           </a:xfrm>
           <a:prstGeom prst="rect">
             <a:avLst/>
@@ -10164,6 +10201,7 @@
           </a:bodyPr>
           <a:lstStyle/>
           <a:p>
+            <a:pPr algn="l"/>
             <a:r>
               <a:rPr lang="en-US" sz="4000" b="1" dirty="0">
                 <a:solidFill>
@@ -10171,7 +10209,7 @@
                 </a:solidFill>
                 <a:latin typeface="Aptos Display"/>
               </a:rPr>
-              <a:t>Design – achieving modularization in DSS</a:t>
+              <a:t>Example: testing a knapsack problem implementation with optimality guaranteed</a:t>
             </a:r>
             <a:endParaRPr sz="4000" b="1" i="0" baseline="30000" dirty="0">
               <a:solidFill>
@@ -10187,7 +10225,7 @@
           <p:cNvPr id="3" name="Slide Number Placeholder 2">
             <a:extLst>
               <a:ext uri="{FF2B5EF4-FFF2-40B4-BE49-F238E27FC236}">
-                <a16:creationId xmlns:a16="http://schemas.microsoft.com/office/drawing/2014/main" id="{45663F89-8D67-7270-5D3C-4D27C3AD8B87}"/>
+                <a16:creationId xmlns:a16="http://schemas.microsoft.com/office/drawing/2014/main" id="{55BF0EC3-F7ED-334F-C1F6-E5FD0A161BDA}"/>
               </a:ext>
             </a:extLst>
           </p:cNvPr>
@@ -10211,10 +10249,1276 @@
           </a:p>
         </p:txBody>
       </p:sp>
+      <p:pic>
+        <p:nvPicPr>
+          <p:cNvPr id="4" name="Picture 3">
+            <a:extLst>
+              <a:ext uri="{FF2B5EF4-FFF2-40B4-BE49-F238E27FC236}">
+                <a16:creationId xmlns:a16="http://schemas.microsoft.com/office/drawing/2014/main" id="{E0302CCA-C7BE-7A17-78FD-A2E8EE6214A9}"/>
+              </a:ext>
+            </a:extLst>
+          </p:cNvPr>
+          <p:cNvPicPr>
+            <a:picLocks noChangeAspect="1"/>
+          </p:cNvPicPr>
+          <p:nvPr/>
+        </p:nvPicPr>
+        <p:blipFill>
+          <a:blip r:embed="rId3"/>
+          <a:stretch>
+            <a:fillRect/>
+          </a:stretch>
+        </p:blipFill>
+        <p:spPr>
+          <a:xfrm>
+            <a:off x="6777857" y="1527825"/>
+            <a:ext cx="1789276" cy="1882558"/>
+          </a:xfrm>
+          <a:prstGeom prst="rect">
+            <a:avLst/>
+          </a:prstGeom>
+        </p:spPr>
+      </p:pic>
+      <mc:AlternateContent xmlns:mc="http://schemas.openxmlformats.org/markup-compatibility/2006" xmlns:a14="http://schemas.microsoft.com/office/drawing/2010/main">
+        <mc:Choice Requires="a14">
+          <p:sp>
+            <p:nvSpPr>
+              <p:cNvPr id="17" name="TextBox 16">
+                <a:extLst>
+                  <a:ext uri="{FF2B5EF4-FFF2-40B4-BE49-F238E27FC236}">
+                    <a16:creationId xmlns:a16="http://schemas.microsoft.com/office/drawing/2014/main" id="{D3A3C4FB-F3AE-EA6C-0921-F3DA73913B77}"/>
+                  </a:ext>
+                </a:extLst>
+              </p:cNvPr>
+              <p:cNvSpPr txBox="1"/>
+              <p:nvPr/>
+            </p:nvSpPr>
+            <p:spPr>
+              <a:xfrm>
+                <a:off x="165489" y="2120747"/>
+                <a:ext cx="2718116" cy="3383747"/>
+              </a:xfrm>
+              <a:prstGeom prst="rect">
+                <a:avLst/>
+              </a:prstGeom>
+              <a:noFill/>
+            </p:spPr>
+            <p:txBody>
+              <a:bodyPr wrap="none" lIns="0" tIns="0" rIns="0" bIns="0" rtlCol="0">
+                <a:spAutoFit/>
+              </a:bodyPr>
+              <a:lstStyle/>
+              <a:p>
+                <a:pPr/>
+                <a14:m>
+                  <m:oMathPara xmlns:m="http://schemas.openxmlformats.org/officeDocument/2006/math">
+                    <m:oMath>
+                      <m:r>
+                        <a:rPr lang="en-US" sz="2800" b="0" i="1" smtClean="0">
+                          <a:latin typeface="Cambria Math" panose="02040503050406030204" pitchFamily="18" charset="0"/>
+                        </a:rPr>
+                        <m:t>𝑀𝑎𝑥</m:t>
+                      </m:r>
+                      <m:r>
+                        <a:rPr lang="en-US" sz="2800" b="0" i="1" smtClean="0">
+                          <a:latin typeface="Cambria Math" panose="02040503050406030204" pitchFamily="18" charset="0"/>
+                        </a:rPr>
+                        <m:t> </m:t>
+                      </m:r>
+                      <m:nary>
+                        <m:naryPr>
+                          <m:chr m:val="∑"/>
+                          <m:supHide m:val="on"/>
+                          <m:ctrlPr>
+                            <a:rPr lang="en-US" sz="2800" b="0" i="1" smtClean="0">
+                              <a:latin typeface="Cambria Math" panose="02040503050406030204" pitchFamily="18" charset="0"/>
+                            </a:rPr>
+                          </m:ctrlPr>
+                        </m:naryPr>
+                        <m:sub>
+                          <m:r>
+                            <a:rPr lang="en-US" sz="2800" b="0" i="1" smtClean="0">
+                              <a:latin typeface="Cambria Math" panose="02040503050406030204" pitchFamily="18" charset="0"/>
+                            </a:rPr>
+                            <m:t>𝑖</m:t>
+                          </m:r>
+                          <m:r>
+                            <a:rPr lang="en-US" sz="2800" b="0" i="1" smtClean="0">
+                              <a:latin typeface="Cambria Math" panose="02040503050406030204" pitchFamily="18" charset="0"/>
+                            </a:rPr>
+                            <m:t>∈</m:t>
+                          </m:r>
+                          <m:r>
+                            <a:rPr lang="en-US" sz="2800" b="0" i="1" smtClean="0">
+                              <a:latin typeface="Cambria Math" panose="02040503050406030204" pitchFamily="18" charset="0"/>
+                            </a:rPr>
+                            <m:t>𝐼</m:t>
+                          </m:r>
+                        </m:sub>
+                        <m:sup/>
+                        <m:e>
+                          <m:sSub>
+                            <m:sSubPr>
+                              <m:ctrlPr>
+                                <a:rPr lang="en-US" sz="2800" b="0" i="1" smtClean="0">
+                                  <a:latin typeface="Cambria Math" panose="02040503050406030204" pitchFamily="18" charset="0"/>
+                                </a:rPr>
+                              </m:ctrlPr>
+                            </m:sSubPr>
+                            <m:e>
+                              <m:r>
+                                <a:rPr lang="en-US" sz="2800" b="0" i="1" smtClean="0">
+                                  <a:latin typeface="Cambria Math" panose="02040503050406030204" pitchFamily="18" charset="0"/>
+                                </a:rPr>
+                                <m:t>𝑐</m:t>
+                              </m:r>
+                            </m:e>
+                            <m:sub>
+                              <m:r>
+                                <a:rPr lang="en-US" sz="2800" b="0" i="1" smtClean="0">
+                                  <a:latin typeface="Cambria Math" panose="02040503050406030204" pitchFamily="18" charset="0"/>
+                                </a:rPr>
+                                <m:t>𝑖</m:t>
+                              </m:r>
+                            </m:sub>
+                          </m:sSub>
+                          <m:sSub>
+                            <m:sSubPr>
+                              <m:ctrlPr>
+                                <a:rPr lang="en-US" sz="2800" b="0" i="1" smtClean="0">
+                                  <a:latin typeface="Cambria Math" panose="02040503050406030204" pitchFamily="18" charset="0"/>
+                                </a:rPr>
+                              </m:ctrlPr>
+                            </m:sSubPr>
+                            <m:e>
+                              <m:r>
+                                <a:rPr lang="en-US" sz="2800" b="0" i="1" smtClean="0">
+                                  <a:latin typeface="Cambria Math" panose="02040503050406030204" pitchFamily="18" charset="0"/>
+                                </a:rPr>
+                                <m:t>𝑥</m:t>
+                              </m:r>
+                            </m:e>
+                            <m:sub>
+                              <m:r>
+                                <a:rPr lang="en-US" sz="2800" b="0" i="1" smtClean="0">
+                                  <a:latin typeface="Cambria Math" panose="02040503050406030204" pitchFamily="18" charset="0"/>
+                                </a:rPr>
+                                <m:t>𝑖</m:t>
+                              </m:r>
+                            </m:sub>
+                          </m:sSub>
+                        </m:e>
+                      </m:nary>
+                    </m:oMath>
+                  </m:oMathPara>
+                </a14:m>
+                <a:endParaRPr lang="en-US" sz="2800" b="0" dirty="0"/>
+              </a:p>
+              <a:p>
+                <a:endParaRPr lang="en-US" sz="2800" b="0" dirty="0"/>
+              </a:p>
+              <a:p>
+                <a:pPr/>
+                <a14:m>
+                  <m:oMathPara xmlns:m="http://schemas.openxmlformats.org/officeDocument/2006/math">
+                    <m:oMath>
+                      <m:nary>
+                        <m:naryPr>
+                          <m:chr m:val="∑"/>
+                          <m:supHide m:val="on"/>
+                          <m:ctrlPr>
+                            <a:rPr lang="en-US" sz="2800" b="0" i="1" smtClean="0">
+                              <a:latin typeface="Cambria Math" panose="02040503050406030204" pitchFamily="18" charset="0"/>
+                            </a:rPr>
+                          </m:ctrlPr>
+                        </m:naryPr>
+                        <m:sub>
+                          <m:r>
+                            <a:rPr lang="en-US" sz="2800" b="0" i="1" smtClean="0">
+                              <a:latin typeface="Cambria Math" panose="02040503050406030204" pitchFamily="18" charset="0"/>
+                            </a:rPr>
+                            <m:t>𝑖</m:t>
+                          </m:r>
+                          <m:r>
+                            <a:rPr lang="en-US" sz="2800" b="0" i="1" smtClean="0">
+                              <a:latin typeface="Cambria Math" panose="02040503050406030204" pitchFamily="18" charset="0"/>
+                            </a:rPr>
+                            <m:t>∈</m:t>
+                          </m:r>
+                          <m:r>
+                            <a:rPr lang="en-US" sz="2800" b="0" i="1" smtClean="0">
+                              <a:latin typeface="Cambria Math" panose="02040503050406030204" pitchFamily="18" charset="0"/>
+                            </a:rPr>
+                            <m:t>𝐼</m:t>
+                          </m:r>
+                        </m:sub>
+                        <m:sup/>
+                        <m:e>
+                          <m:sSub>
+                            <m:sSubPr>
+                              <m:ctrlPr>
+                                <a:rPr lang="en-US" sz="2800" b="0" i="1" smtClean="0">
+                                  <a:latin typeface="Cambria Math" panose="02040503050406030204" pitchFamily="18" charset="0"/>
+                                </a:rPr>
+                              </m:ctrlPr>
+                            </m:sSubPr>
+                            <m:e>
+                              <m:r>
+                                <a:rPr lang="en-US" sz="2800" b="0" i="1" smtClean="0">
+                                  <a:latin typeface="Cambria Math" panose="02040503050406030204" pitchFamily="18" charset="0"/>
+                                </a:rPr>
+                                <m:t>𝑤</m:t>
+                              </m:r>
+                            </m:e>
+                            <m:sub>
+                              <m:r>
+                                <a:rPr lang="en-US" sz="2800" b="0" i="1" smtClean="0">
+                                  <a:latin typeface="Cambria Math" panose="02040503050406030204" pitchFamily="18" charset="0"/>
+                                </a:rPr>
+                                <m:t>𝑖</m:t>
+                              </m:r>
+                            </m:sub>
+                          </m:sSub>
+                          <m:sSub>
+                            <m:sSubPr>
+                              <m:ctrlPr>
+                                <a:rPr lang="en-US" sz="2800" b="0" i="1" smtClean="0">
+                                  <a:latin typeface="Cambria Math" panose="02040503050406030204" pitchFamily="18" charset="0"/>
+                                </a:rPr>
+                              </m:ctrlPr>
+                            </m:sSubPr>
+                            <m:e>
+                              <m:r>
+                                <a:rPr lang="en-US" sz="2800" b="0" i="1" smtClean="0">
+                                  <a:latin typeface="Cambria Math" panose="02040503050406030204" pitchFamily="18" charset="0"/>
+                                </a:rPr>
+                                <m:t>𝑥</m:t>
+                              </m:r>
+                            </m:e>
+                            <m:sub>
+                              <m:r>
+                                <a:rPr lang="en-US" sz="2800" b="0" i="1" smtClean="0">
+                                  <a:latin typeface="Cambria Math" panose="02040503050406030204" pitchFamily="18" charset="0"/>
+                                </a:rPr>
+                                <m:t>𝑖</m:t>
+                              </m:r>
+                            </m:sub>
+                          </m:sSub>
+                          <m:r>
+                            <a:rPr lang="en-US" sz="2800" b="0" i="1" smtClean="0">
+                              <a:latin typeface="Cambria Math" panose="02040503050406030204" pitchFamily="18" charset="0"/>
+                            </a:rPr>
+                            <m:t>≤</m:t>
+                          </m:r>
+                          <m:r>
+                            <a:rPr lang="en-US" sz="2800" b="0" i="1" smtClean="0">
+                              <a:latin typeface="Cambria Math" panose="02040503050406030204" pitchFamily="18" charset="0"/>
+                            </a:rPr>
+                            <m:t>𝑊</m:t>
+                          </m:r>
+                        </m:e>
+                      </m:nary>
+                    </m:oMath>
+                  </m:oMathPara>
+                </a14:m>
+                <a:endParaRPr lang="en-US" sz="2800" b="0" dirty="0"/>
+              </a:p>
+              <a:p>
+                <a:endParaRPr lang="en-US" sz="2800" b="0" dirty="0"/>
+              </a:p>
+              <a:p>
+                <a:pPr/>
+                <a14:m>
+                  <m:oMathPara xmlns:m="http://schemas.openxmlformats.org/officeDocument/2006/math">
+                    <m:oMath>
+                      <m:sSub>
+                        <m:sSubPr>
+                          <m:ctrlPr>
+                            <a:rPr lang="en-US" sz="2800" b="0" i="1" smtClean="0">
+                              <a:latin typeface="Cambria Math" panose="02040503050406030204" pitchFamily="18" charset="0"/>
+                            </a:rPr>
+                          </m:ctrlPr>
+                        </m:sSubPr>
+                        <m:e>
+                          <m:r>
+                            <a:rPr lang="en-US" sz="2800" b="0" i="1" smtClean="0">
+                              <a:latin typeface="Cambria Math" panose="02040503050406030204" pitchFamily="18" charset="0"/>
+                            </a:rPr>
+                            <m:t>𝑥</m:t>
+                          </m:r>
+                        </m:e>
+                        <m:sub>
+                          <m:r>
+                            <a:rPr lang="en-US" sz="2800" b="0" i="1" smtClean="0">
+                              <a:latin typeface="Cambria Math" panose="02040503050406030204" pitchFamily="18" charset="0"/>
+                            </a:rPr>
+                            <m:t>𝑖</m:t>
+                          </m:r>
+                        </m:sub>
+                      </m:sSub>
+                      <m:r>
+                        <a:rPr lang="en-US" sz="2800" b="0" i="1" smtClean="0">
+                          <a:latin typeface="Cambria Math" panose="02040503050406030204" pitchFamily="18" charset="0"/>
+                        </a:rPr>
+                        <m:t>∈</m:t>
+                      </m:r>
+                      <m:d>
+                        <m:dPr>
+                          <m:begChr m:val="{"/>
+                          <m:endChr m:val="}"/>
+                          <m:ctrlPr>
+                            <a:rPr lang="en-US" sz="2800" b="0" i="1" smtClean="0">
+                              <a:latin typeface="Cambria Math" panose="02040503050406030204" pitchFamily="18" charset="0"/>
+                            </a:rPr>
+                          </m:ctrlPr>
+                        </m:dPr>
+                        <m:e>
+                          <m:r>
+                            <a:rPr lang="en-US" sz="2800" b="0" i="1" smtClean="0">
+                              <a:latin typeface="Cambria Math" panose="02040503050406030204" pitchFamily="18" charset="0"/>
+                            </a:rPr>
+                            <m:t>0,1</m:t>
+                          </m:r>
+                        </m:e>
+                      </m:d>
+                      <m:r>
+                        <a:rPr lang="en-US" sz="2800" b="0" i="1" smtClean="0">
+                          <a:latin typeface="Cambria Math" panose="02040503050406030204" pitchFamily="18" charset="0"/>
+                        </a:rPr>
+                        <m:t> ∀ </m:t>
+                      </m:r>
+                      <m:r>
+                        <a:rPr lang="en-US" sz="2800" b="0" i="1" smtClean="0">
+                          <a:latin typeface="Cambria Math" panose="02040503050406030204" pitchFamily="18" charset="0"/>
+                        </a:rPr>
+                        <m:t>𝑖</m:t>
+                      </m:r>
+                      <m:r>
+                        <a:rPr lang="en-US" sz="2800" b="0" i="1" smtClean="0">
+                          <a:latin typeface="Cambria Math" panose="02040503050406030204" pitchFamily="18" charset="0"/>
+                        </a:rPr>
+                        <m:t>∈</m:t>
+                      </m:r>
+                      <m:r>
+                        <a:rPr lang="en-US" sz="2800" b="0" i="1" smtClean="0">
+                          <a:latin typeface="Cambria Math" panose="02040503050406030204" pitchFamily="18" charset="0"/>
+                        </a:rPr>
+                        <m:t>𝐼</m:t>
+                      </m:r>
+                    </m:oMath>
+                  </m:oMathPara>
+                </a14:m>
+                <a:endParaRPr lang="en-US" sz="2800" dirty="0"/>
+              </a:p>
+            </p:txBody>
+          </p:sp>
+        </mc:Choice>
+        <mc:Fallback xmlns="">
+          <p:sp>
+            <p:nvSpPr>
+              <p:cNvPr id="17" name="TextBox 16">
+                <a:extLst>
+                  <a:ext uri="{FF2B5EF4-FFF2-40B4-BE49-F238E27FC236}">
+                    <a16:creationId xmlns:a16="http://schemas.microsoft.com/office/drawing/2014/main" id="{D3A3C4FB-F3AE-EA6C-0921-F3DA73913B77}"/>
+                  </a:ext>
+                </a:extLst>
+              </p:cNvPr>
+              <p:cNvSpPr txBox="1">
+                <a:spLocks noRot="1" noChangeAspect="1" noMove="1" noResize="1" noEditPoints="1" noAdjustHandles="1" noChangeArrowheads="1" noChangeShapeType="1" noTextEdit="1"/>
+              </p:cNvSpPr>
+              <p:nvPr/>
+            </p:nvSpPr>
+            <p:spPr>
+              <a:xfrm>
+                <a:off x="165489" y="2120747"/>
+                <a:ext cx="2718116" cy="3383747"/>
+              </a:xfrm>
+              <a:prstGeom prst="rect">
+                <a:avLst/>
+              </a:prstGeom>
+              <a:blipFill>
+                <a:blip r:embed="rId4"/>
+                <a:stretch>
+                  <a:fillRect/>
+                </a:stretch>
+              </a:blipFill>
+            </p:spPr>
+            <p:txBody>
+              <a:bodyPr/>
+              <a:lstStyle/>
+              <a:p>
+                <a:r>
+                  <a:rPr lang="en-US">
+                    <a:noFill/>
+                  </a:rPr>
+                  <a:t> </a:t>
+                </a:r>
+              </a:p>
+            </p:txBody>
+          </p:sp>
+        </mc:Fallback>
+      </mc:AlternateContent>
+      <p:sp>
+        <p:nvSpPr>
+          <p:cNvPr id="19" name="TextBox 18">
+            <a:extLst>
+              <a:ext uri="{FF2B5EF4-FFF2-40B4-BE49-F238E27FC236}">
+                <a16:creationId xmlns:a16="http://schemas.microsoft.com/office/drawing/2014/main" id="{E03B33AF-DA41-0FE5-98D9-A26D64101697}"/>
+              </a:ext>
+            </a:extLst>
+          </p:cNvPr>
+          <p:cNvSpPr txBox="1"/>
+          <p:nvPr/>
+        </p:nvSpPr>
+        <p:spPr>
+          <a:xfrm>
+            <a:off x="3118475" y="2431203"/>
+            <a:ext cx="2718116" cy="461665"/>
+          </a:xfrm>
+          <a:prstGeom prst="rect">
+            <a:avLst/>
+          </a:prstGeom>
+          <a:noFill/>
+        </p:spPr>
+        <p:txBody>
+          <a:bodyPr wrap="square">
+            <a:spAutoFit/>
+          </a:bodyPr>
+          <a:lstStyle/>
+          <a:p>
+            <a:r>
+              <a:rPr lang="en-US" sz="2400" b="1" dirty="0">
+                <a:solidFill>
+                  <a:srgbClr val="0F2343"/>
+                </a:solidFill>
+                <a:latin typeface="Aptos"/>
+                <a:sym typeface="Wingdings" panose="05000000000000000000" pitchFamily="2" charset="2"/>
+              </a:rPr>
+              <a:t>Maximize calories</a:t>
+            </a:r>
+            <a:endParaRPr lang="en-US" sz="2000" b="1" dirty="0"/>
+          </a:p>
+        </p:txBody>
+      </p:sp>
+      <p:sp>
+        <p:nvSpPr>
+          <p:cNvPr id="21" name="TextBox 20">
+            <a:extLst>
+              <a:ext uri="{FF2B5EF4-FFF2-40B4-BE49-F238E27FC236}">
+                <a16:creationId xmlns:a16="http://schemas.microsoft.com/office/drawing/2014/main" id="{2C291444-1ED0-293C-7222-A656FEC349AD}"/>
+              </a:ext>
+            </a:extLst>
+          </p:cNvPr>
+          <p:cNvSpPr txBox="1"/>
+          <p:nvPr/>
+        </p:nvSpPr>
+        <p:spPr>
+          <a:xfrm>
+            <a:off x="3118475" y="3809597"/>
+            <a:ext cx="2718116" cy="461665"/>
+          </a:xfrm>
+          <a:prstGeom prst="rect">
+            <a:avLst/>
+          </a:prstGeom>
+          <a:noFill/>
+        </p:spPr>
+        <p:txBody>
+          <a:bodyPr wrap="square">
+            <a:spAutoFit/>
+          </a:bodyPr>
+          <a:lstStyle/>
+          <a:p>
+            <a:r>
+              <a:rPr lang="en-US" sz="2400" b="1" dirty="0">
+                <a:solidFill>
+                  <a:srgbClr val="0F2343"/>
+                </a:solidFill>
+                <a:latin typeface="Aptos"/>
+                <a:sym typeface="Wingdings" panose="05000000000000000000" pitchFamily="2" charset="2"/>
+              </a:rPr>
+              <a:t>Weight capacity</a:t>
+            </a:r>
+            <a:endParaRPr lang="en-US" sz="2000" b="1" dirty="0"/>
+          </a:p>
+        </p:txBody>
+      </p:sp>
+      <p:sp>
+        <p:nvSpPr>
+          <p:cNvPr id="22" name="TextBox 21">
+            <a:extLst>
+              <a:ext uri="{FF2B5EF4-FFF2-40B4-BE49-F238E27FC236}">
+                <a16:creationId xmlns:a16="http://schemas.microsoft.com/office/drawing/2014/main" id="{39188F39-2439-1717-7376-095B9271417D}"/>
+              </a:ext>
+            </a:extLst>
+          </p:cNvPr>
+          <p:cNvSpPr txBox="1"/>
+          <p:nvPr/>
+        </p:nvSpPr>
+        <p:spPr>
+          <a:xfrm>
+            <a:off x="3144915" y="5027410"/>
+            <a:ext cx="2718116" cy="461665"/>
+          </a:xfrm>
+          <a:prstGeom prst="rect">
+            <a:avLst/>
+          </a:prstGeom>
+          <a:noFill/>
+        </p:spPr>
+        <p:txBody>
+          <a:bodyPr wrap="square">
+            <a:spAutoFit/>
+          </a:bodyPr>
+          <a:lstStyle/>
+          <a:p>
+            <a:r>
+              <a:rPr lang="en-US" sz="2400" b="1" dirty="0">
+                <a:solidFill>
+                  <a:srgbClr val="0F2343"/>
+                </a:solidFill>
+                <a:latin typeface="Aptos"/>
+                <a:sym typeface="Wingdings" panose="05000000000000000000" pitchFamily="2" charset="2"/>
+              </a:rPr>
+              <a:t>Binary decisions</a:t>
+            </a:r>
+            <a:endParaRPr lang="en-US" sz="2000" b="1" dirty="0"/>
+          </a:p>
+        </p:txBody>
+      </p:sp>
+      <p:graphicFrame>
+        <p:nvGraphicFramePr>
+          <p:cNvPr id="25" name="Table 24">
+            <a:extLst>
+              <a:ext uri="{FF2B5EF4-FFF2-40B4-BE49-F238E27FC236}">
+                <a16:creationId xmlns:a16="http://schemas.microsoft.com/office/drawing/2014/main" id="{D1DFDE02-F492-3C02-824F-E4020E4A6C39}"/>
+              </a:ext>
+            </a:extLst>
+          </p:cNvPr>
+          <p:cNvGraphicFramePr>
+            <a:graphicFrameLocks noGrp="1"/>
+          </p:cNvGraphicFramePr>
+          <p:nvPr>
+            <p:extLst>
+              <p:ext uri="{D42A27DB-BD31-4B8C-83A1-F6EECF244321}">
+                <p14:modId xmlns:p14="http://schemas.microsoft.com/office/powerpoint/2010/main" val="172526017"/>
+              </p:ext>
+            </p:extLst>
+          </p:nvPr>
+        </p:nvGraphicFramePr>
+        <p:xfrm>
+          <a:off x="6997313" y="3586625"/>
+          <a:ext cx="4595890" cy="1463040"/>
+        </p:xfrm>
+        <a:graphic>
+          <a:graphicData uri="http://schemas.openxmlformats.org/drawingml/2006/table">
+            <a:tbl>
+              <a:tblPr firstRow="1" bandRow="1">
+                <a:tableStyleId>{5C22544A-7EE6-4342-B048-85BDC9FD1C3A}</a:tableStyleId>
+              </a:tblPr>
+              <a:tblGrid>
+                <a:gridCol w="1961492">
+                  <a:extLst>
+                    <a:ext uri="{9D8B030D-6E8A-4147-A177-3AD203B41FA5}">
+                      <a16:colId xmlns:a16="http://schemas.microsoft.com/office/drawing/2014/main" val="20000"/>
+                    </a:ext>
+                  </a:extLst>
+                </a:gridCol>
+                <a:gridCol w="1354238">
+                  <a:extLst>
+                    <a:ext uri="{9D8B030D-6E8A-4147-A177-3AD203B41FA5}">
+                      <a16:colId xmlns:a16="http://schemas.microsoft.com/office/drawing/2014/main" val="20001"/>
+                    </a:ext>
+                  </a:extLst>
+                </a:gridCol>
+                <a:gridCol w="1280160">
+                  <a:extLst>
+                    <a:ext uri="{9D8B030D-6E8A-4147-A177-3AD203B41FA5}">
+                      <a16:colId xmlns:a16="http://schemas.microsoft.com/office/drawing/2014/main" val="20002"/>
+                    </a:ext>
+                  </a:extLst>
+                </a:gridCol>
+              </a:tblGrid>
+              <a:tr h="365760">
+                <a:tc>
+                  <a:txBody>
+                    <a:bodyPr/>
+                    <a:lstStyle/>
+                    <a:p>
+                      <a:pPr algn="l">
+                        <a:spcBef>
+                          <a:spcPts val="0"/>
+                        </a:spcBef>
+                        <a:spcAft>
+                          <a:spcPts val="0"/>
+                        </a:spcAft>
+                      </a:pPr>
+                      <a:r>
+                        <a:rPr lang="en-US" sz="1800" b="1" dirty="0">
+                          <a:solidFill>
+                            <a:srgbClr val="FFFFFF"/>
+                          </a:solidFill>
+                          <a:latin typeface="Aptos"/>
+                        </a:rPr>
+                        <a:t>Item</a:t>
+                      </a:r>
+                      <a:endParaRPr sz="1800" b="1" dirty="0">
+                        <a:solidFill>
+                          <a:srgbClr val="FFFFFF"/>
+                        </a:solidFill>
+                        <a:latin typeface="Aptos"/>
+                      </a:endParaRPr>
+                    </a:p>
+                  </a:txBody>
+                  <a:tcPr marL="128016" marR="109728" anchor="ctr">
+                    <a:solidFill>
+                      <a:srgbClr val="0F2343"/>
+                    </a:solidFill>
+                  </a:tcPr>
+                </a:tc>
+                <a:tc>
+                  <a:txBody>
+                    <a:bodyPr/>
+                    <a:lstStyle/>
+                    <a:p>
+                      <a:pPr algn="r">
+                        <a:spcBef>
+                          <a:spcPts val="0"/>
+                        </a:spcBef>
+                        <a:spcAft>
+                          <a:spcPts val="0"/>
+                        </a:spcAft>
+                      </a:pPr>
+                      <a:r>
+                        <a:rPr sz="1800" b="1" dirty="0">
+                          <a:solidFill>
+                            <a:srgbClr val="FFFFFF"/>
+                          </a:solidFill>
+                          <a:latin typeface="Aptos"/>
+                        </a:rPr>
+                        <a:t>Weight</a:t>
+                      </a:r>
+                    </a:p>
+                  </a:txBody>
+                  <a:tcPr marL="128016" marR="109728" anchor="ctr">
+                    <a:solidFill>
+                      <a:srgbClr val="0F2343"/>
+                    </a:solidFill>
+                  </a:tcPr>
+                </a:tc>
+                <a:tc>
+                  <a:txBody>
+                    <a:bodyPr/>
+                    <a:lstStyle/>
+                    <a:p>
+                      <a:pPr algn="r">
+                        <a:spcBef>
+                          <a:spcPts val="0"/>
+                        </a:spcBef>
+                        <a:spcAft>
+                          <a:spcPts val="0"/>
+                        </a:spcAft>
+                      </a:pPr>
+                      <a:r>
+                        <a:rPr lang="en-US" sz="1800" b="1" dirty="0">
+                          <a:solidFill>
+                            <a:srgbClr val="FFFFFF"/>
+                          </a:solidFill>
+                          <a:latin typeface="Aptos"/>
+                        </a:rPr>
+                        <a:t>Calories</a:t>
+                      </a:r>
+                      <a:endParaRPr sz="1800" b="1" dirty="0">
+                        <a:solidFill>
+                          <a:srgbClr val="FFFFFF"/>
+                        </a:solidFill>
+                        <a:latin typeface="Aptos"/>
+                      </a:endParaRPr>
+                    </a:p>
+                  </a:txBody>
+                  <a:tcPr marL="128016" marR="109728" anchor="ctr">
+                    <a:solidFill>
+                      <a:srgbClr val="0F2343"/>
+                    </a:solidFill>
+                  </a:tcPr>
+                </a:tc>
+                <a:extLst>
+                  <a:ext uri="{0D108BD9-81ED-4DB2-BD59-A6C34878D82A}">
+                    <a16:rowId xmlns:a16="http://schemas.microsoft.com/office/drawing/2014/main" val="10000"/>
+                  </a:ext>
+                </a:extLst>
+              </a:tr>
+              <a:tr h="365760">
+                <a:tc>
+                  <a:txBody>
+                    <a:bodyPr/>
+                    <a:lstStyle/>
+                    <a:p>
+                      <a:pPr algn="l">
+                        <a:spcBef>
+                          <a:spcPts val="0"/>
+                        </a:spcBef>
+                        <a:spcAft>
+                          <a:spcPts val="0"/>
+                        </a:spcAft>
+                      </a:pPr>
+                      <a:r>
+                        <a:rPr lang="en-US" sz="1800" b="0" dirty="0">
+                          <a:solidFill>
+                            <a:srgbClr val="0F2343"/>
+                          </a:solidFill>
+                          <a:latin typeface="Aptos"/>
+                        </a:rPr>
+                        <a:t>Chocolate</a:t>
+                      </a:r>
+                      <a:endParaRPr sz="1800" b="0" dirty="0">
+                        <a:solidFill>
+                          <a:srgbClr val="0F2343"/>
+                        </a:solidFill>
+                        <a:latin typeface="Aptos"/>
+                      </a:endParaRPr>
+                    </a:p>
+                  </a:txBody>
+                  <a:tcPr marL="128016" marR="109728" anchor="ctr">
+                    <a:solidFill>
+                      <a:srgbClr val="FFFFFF"/>
+                    </a:solidFill>
+                  </a:tcPr>
+                </a:tc>
+                <a:tc>
+                  <a:txBody>
+                    <a:bodyPr/>
+                    <a:lstStyle/>
+                    <a:p>
+                      <a:pPr algn="r">
+                        <a:spcBef>
+                          <a:spcPts val="0"/>
+                        </a:spcBef>
+                        <a:spcAft>
+                          <a:spcPts val="0"/>
+                        </a:spcAft>
+                      </a:pPr>
+                      <a:r>
+                        <a:rPr lang="en-US" sz="1800" b="0" dirty="0">
+                          <a:solidFill>
+                            <a:srgbClr val="0F2343"/>
+                          </a:solidFill>
+                          <a:latin typeface="Aptos"/>
+                        </a:rPr>
+                        <a:t>500</a:t>
+                      </a:r>
+                      <a:endParaRPr sz="1800" b="0" dirty="0">
+                        <a:solidFill>
+                          <a:srgbClr val="0F2343"/>
+                        </a:solidFill>
+                        <a:latin typeface="Aptos"/>
+                      </a:endParaRPr>
+                    </a:p>
+                  </a:txBody>
+                  <a:tcPr marL="128016" marR="109728" anchor="ctr">
+                    <a:solidFill>
+                      <a:srgbClr val="FFFFFF"/>
+                    </a:solidFill>
+                  </a:tcPr>
+                </a:tc>
+                <a:tc>
+                  <a:txBody>
+                    <a:bodyPr/>
+                    <a:lstStyle/>
+                    <a:p>
+                      <a:pPr algn="r">
+                        <a:spcBef>
+                          <a:spcPts val="0"/>
+                        </a:spcBef>
+                        <a:spcAft>
+                          <a:spcPts val="0"/>
+                        </a:spcAft>
+                      </a:pPr>
+                      <a:r>
+                        <a:rPr lang="en-US" sz="1800" b="0" dirty="0">
+                          <a:solidFill>
+                            <a:srgbClr val="0F2343"/>
+                          </a:solidFill>
+                          <a:latin typeface="Aptos"/>
+                        </a:rPr>
+                        <a:t>300</a:t>
+                      </a:r>
+                      <a:endParaRPr sz="1800" b="0" dirty="0">
+                        <a:solidFill>
+                          <a:srgbClr val="0F2343"/>
+                        </a:solidFill>
+                        <a:latin typeface="Aptos"/>
+                      </a:endParaRPr>
+                    </a:p>
+                  </a:txBody>
+                  <a:tcPr marL="128016" marR="109728" anchor="ctr">
+                    <a:solidFill>
+                      <a:srgbClr val="FFFFFF"/>
+                    </a:solidFill>
+                  </a:tcPr>
+                </a:tc>
+                <a:extLst>
+                  <a:ext uri="{0D108BD9-81ED-4DB2-BD59-A6C34878D82A}">
+                    <a16:rowId xmlns:a16="http://schemas.microsoft.com/office/drawing/2014/main" val="10001"/>
+                  </a:ext>
+                </a:extLst>
+              </a:tr>
+              <a:tr h="365760">
+                <a:tc>
+                  <a:txBody>
+                    <a:bodyPr/>
+                    <a:lstStyle/>
+                    <a:p>
+                      <a:pPr algn="l">
+                        <a:spcBef>
+                          <a:spcPts val="0"/>
+                        </a:spcBef>
+                        <a:spcAft>
+                          <a:spcPts val="0"/>
+                        </a:spcAft>
+                      </a:pPr>
+                      <a:r>
+                        <a:rPr lang="en-US" sz="1800" b="1" dirty="0">
+                          <a:solidFill>
+                            <a:srgbClr val="0F2343"/>
+                          </a:solidFill>
+                          <a:latin typeface="Aptos"/>
+                        </a:rPr>
+                        <a:t>Peanuts</a:t>
+                      </a:r>
+                      <a:endParaRPr sz="1800" b="1" dirty="0">
+                        <a:solidFill>
+                          <a:srgbClr val="0F2343"/>
+                        </a:solidFill>
+                        <a:latin typeface="Aptos"/>
+                      </a:endParaRPr>
+                    </a:p>
+                  </a:txBody>
+                  <a:tcPr marL="128016" marR="109728" anchor="ctr">
+                    <a:solidFill>
+                      <a:srgbClr val="81F17B"/>
+                    </a:solidFill>
+                  </a:tcPr>
+                </a:tc>
+                <a:tc>
+                  <a:txBody>
+                    <a:bodyPr/>
+                    <a:lstStyle/>
+                    <a:p>
+                      <a:pPr algn="r">
+                        <a:spcBef>
+                          <a:spcPts val="0"/>
+                        </a:spcBef>
+                        <a:spcAft>
+                          <a:spcPts val="0"/>
+                        </a:spcAft>
+                      </a:pPr>
+                      <a:r>
+                        <a:rPr lang="en-US" sz="1800" b="1" dirty="0">
+                          <a:solidFill>
+                            <a:srgbClr val="0F2343"/>
+                          </a:solidFill>
+                          <a:latin typeface="Aptos"/>
+                        </a:rPr>
+                        <a:t>250</a:t>
+                      </a:r>
+                      <a:endParaRPr sz="1800" b="1" dirty="0">
+                        <a:solidFill>
+                          <a:srgbClr val="0F2343"/>
+                        </a:solidFill>
+                        <a:latin typeface="Aptos"/>
+                      </a:endParaRPr>
+                    </a:p>
+                  </a:txBody>
+                  <a:tcPr marL="128016" marR="109728" anchor="ctr">
+                    <a:solidFill>
+                      <a:srgbClr val="81F17B"/>
+                    </a:solidFill>
+                  </a:tcPr>
+                </a:tc>
+                <a:tc>
+                  <a:txBody>
+                    <a:bodyPr/>
+                    <a:lstStyle/>
+                    <a:p>
+                      <a:pPr algn="r">
+                        <a:spcBef>
+                          <a:spcPts val="0"/>
+                        </a:spcBef>
+                        <a:spcAft>
+                          <a:spcPts val="0"/>
+                        </a:spcAft>
+                      </a:pPr>
+                      <a:r>
+                        <a:rPr lang="en-US" sz="1800" b="1" dirty="0">
+                          <a:solidFill>
+                            <a:srgbClr val="0F2343"/>
+                          </a:solidFill>
+                          <a:latin typeface="Aptos"/>
+                        </a:rPr>
+                        <a:t>200</a:t>
+                      </a:r>
+                      <a:endParaRPr sz="1800" b="1" dirty="0">
+                        <a:solidFill>
+                          <a:srgbClr val="0F2343"/>
+                        </a:solidFill>
+                        <a:latin typeface="Aptos"/>
+                      </a:endParaRPr>
+                    </a:p>
+                  </a:txBody>
+                  <a:tcPr marL="128016" marR="109728" anchor="ctr">
+                    <a:solidFill>
+                      <a:srgbClr val="81F17B"/>
+                    </a:solidFill>
+                  </a:tcPr>
+                </a:tc>
+                <a:extLst>
+                  <a:ext uri="{0D108BD9-81ED-4DB2-BD59-A6C34878D82A}">
+                    <a16:rowId xmlns:a16="http://schemas.microsoft.com/office/drawing/2014/main" val="10002"/>
+                  </a:ext>
+                </a:extLst>
+              </a:tr>
+              <a:tr h="365760">
+                <a:tc>
+                  <a:txBody>
+                    <a:bodyPr/>
+                    <a:lstStyle/>
+                    <a:p>
+                      <a:pPr algn="l">
+                        <a:spcBef>
+                          <a:spcPts val="0"/>
+                        </a:spcBef>
+                        <a:spcAft>
+                          <a:spcPts val="0"/>
+                        </a:spcAft>
+                      </a:pPr>
+                      <a:r>
+                        <a:rPr lang="en-US" sz="1800" b="1" dirty="0">
+                          <a:solidFill>
+                            <a:srgbClr val="0F2343"/>
+                          </a:solidFill>
+                          <a:latin typeface="Aptos"/>
+                        </a:rPr>
+                        <a:t>Cheese</a:t>
+                      </a:r>
+                      <a:endParaRPr sz="1800" b="1" dirty="0">
+                        <a:solidFill>
+                          <a:srgbClr val="0F2343"/>
+                        </a:solidFill>
+                        <a:latin typeface="Aptos"/>
+                      </a:endParaRPr>
+                    </a:p>
+                  </a:txBody>
+                  <a:tcPr marL="128016" marR="109728" anchor="ctr">
+                    <a:solidFill>
+                      <a:srgbClr val="81F17B"/>
+                    </a:solidFill>
+                  </a:tcPr>
+                </a:tc>
+                <a:tc>
+                  <a:txBody>
+                    <a:bodyPr/>
+                    <a:lstStyle/>
+                    <a:p>
+                      <a:pPr algn="r">
+                        <a:spcBef>
+                          <a:spcPts val="0"/>
+                        </a:spcBef>
+                        <a:spcAft>
+                          <a:spcPts val="0"/>
+                        </a:spcAft>
+                      </a:pPr>
+                      <a:r>
+                        <a:rPr lang="en-US" sz="1800" b="1" dirty="0">
+                          <a:solidFill>
+                            <a:srgbClr val="0F2343"/>
+                          </a:solidFill>
+                          <a:latin typeface="Aptos"/>
+                        </a:rPr>
+                        <a:t>250</a:t>
+                      </a:r>
+                      <a:endParaRPr sz="1800" b="1" dirty="0">
+                        <a:solidFill>
+                          <a:srgbClr val="0F2343"/>
+                        </a:solidFill>
+                        <a:latin typeface="Aptos"/>
+                      </a:endParaRPr>
+                    </a:p>
+                  </a:txBody>
+                  <a:tcPr marL="128016" marR="109728" anchor="ctr">
+                    <a:solidFill>
+                      <a:srgbClr val="81F17B"/>
+                    </a:solidFill>
+                  </a:tcPr>
+                </a:tc>
+                <a:tc>
+                  <a:txBody>
+                    <a:bodyPr/>
+                    <a:lstStyle/>
+                    <a:p>
+                      <a:pPr algn="r">
+                        <a:spcBef>
+                          <a:spcPts val="0"/>
+                        </a:spcBef>
+                        <a:spcAft>
+                          <a:spcPts val="0"/>
+                        </a:spcAft>
+                      </a:pPr>
+                      <a:r>
+                        <a:rPr lang="en-US" sz="1800" b="1" dirty="0">
+                          <a:solidFill>
+                            <a:srgbClr val="0F2343"/>
+                          </a:solidFill>
+                          <a:latin typeface="Aptos"/>
+                        </a:rPr>
+                        <a:t>150</a:t>
+                      </a:r>
+                      <a:endParaRPr sz="1800" b="1" dirty="0">
+                        <a:solidFill>
+                          <a:srgbClr val="0F2343"/>
+                        </a:solidFill>
+                        <a:latin typeface="Aptos"/>
+                      </a:endParaRPr>
+                    </a:p>
+                  </a:txBody>
+                  <a:tcPr marL="128016" marR="109728" anchor="ctr">
+                    <a:solidFill>
+                      <a:srgbClr val="81F17B"/>
+                    </a:solidFill>
+                  </a:tcPr>
+                </a:tc>
+                <a:extLst>
+                  <a:ext uri="{0D108BD9-81ED-4DB2-BD59-A6C34878D82A}">
+                    <a16:rowId xmlns:a16="http://schemas.microsoft.com/office/drawing/2014/main" val="10003"/>
+                  </a:ext>
+                </a:extLst>
+              </a:tr>
+            </a:tbl>
+          </a:graphicData>
+        </a:graphic>
+      </p:graphicFrame>
+      <p:sp>
+        <p:nvSpPr>
+          <p:cNvPr id="27" name="Text: ✓">
+            <a:extLst>
+              <a:ext uri="{FF2B5EF4-FFF2-40B4-BE49-F238E27FC236}">
+                <a16:creationId xmlns:a16="http://schemas.microsoft.com/office/drawing/2014/main" id="{F7ECE24D-2992-3F4E-6F19-9BEDACF0E9D6}"/>
+              </a:ext>
+            </a:extLst>
+          </p:cNvPr>
+          <p:cNvSpPr txBox="1"/>
+          <p:nvPr/>
+        </p:nvSpPr>
+        <p:spPr>
+          <a:xfrm>
+            <a:off x="6622409" y="4311983"/>
+            <a:ext cx="310896" cy="384048"/>
+          </a:xfrm>
+          <a:prstGeom prst="rect">
+            <a:avLst/>
+          </a:prstGeom>
+          <a:noFill/>
+        </p:spPr>
+        <p:txBody>
+          <a:bodyPr wrap="square" lIns="0" tIns="0" rIns="0" bIns="0" anchor="ctr">
+            <a:noAutofit/>
+          </a:bodyPr>
+          <a:lstStyle/>
+          <a:p>
+            <a:pPr algn="ctr">
+              <a:lnSpc>
+                <a:spcPct val="106000"/>
+              </a:lnSpc>
+              <a:spcBef>
+                <a:spcPts val="0"/>
+              </a:spcBef>
+              <a:spcAft>
+                <a:spcPts val="0"/>
+              </a:spcAft>
+            </a:pPr>
+            <a:r>
+              <a:rPr sz="2100" b="1" dirty="0">
+                <a:solidFill>
+                  <a:srgbClr val="00B050"/>
+                </a:solidFill>
+                <a:latin typeface="Segoe UI Symbol"/>
+              </a:rPr>
+              <a:t>✓</a:t>
+            </a:r>
+          </a:p>
+        </p:txBody>
+      </p:sp>
+      <p:sp>
+        <p:nvSpPr>
+          <p:cNvPr id="29" name="Text: ✓">
+            <a:extLst>
+              <a:ext uri="{FF2B5EF4-FFF2-40B4-BE49-F238E27FC236}">
+                <a16:creationId xmlns:a16="http://schemas.microsoft.com/office/drawing/2014/main" id="{97E21F06-ED57-180A-D55F-B0B4CE593F74}"/>
+              </a:ext>
+            </a:extLst>
+          </p:cNvPr>
+          <p:cNvSpPr txBox="1"/>
+          <p:nvPr/>
+        </p:nvSpPr>
+        <p:spPr>
+          <a:xfrm>
+            <a:off x="6622409" y="4713764"/>
+            <a:ext cx="310896" cy="384048"/>
+          </a:xfrm>
+          <a:prstGeom prst="rect">
+            <a:avLst/>
+          </a:prstGeom>
+          <a:noFill/>
+        </p:spPr>
+        <p:txBody>
+          <a:bodyPr wrap="square" lIns="0" tIns="0" rIns="0" bIns="0" anchor="ctr">
+            <a:noAutofit/>
+          </a:bodyPr>
+          <a:lstStyle/>
+          <a:p>
+            <a:pPr algn="ctr">
+              <a:lnSpc>
+                <a:spcPct val="106000"/>
+              </a:lnSpc>
+              <a:spcBef>
+                <a:spcPts val="0"/>
+              </a:spcBef>
+              <a:spcAft>
+                <a:spcPts val="0"/>
+              </a:spcAft>
+            </a:pPr>
+            <a:r>
+              <a:rPr sz="2100" b="1" dirty="0">
+                <a:solidFill>
+                  <a:srgbClr val="00B050"/>
+                </a:solidFill>
+                <a:latin typeface="Segoe UI Symbol"/>
+              </a:rPr>
+              <a:t>✓</a:t>
+            </a:r>
+          </a:p>
+        </p:txBody>
+      </p:sp>
+      <p:sp>
+        <p:nvSpPr>
+          <p:cNvPr id="30" name="TextBox 29">
+            <a:extLst>
+              <a:ext uri="{FF2B5EF4-FFF2-40B4-BE49-F238E27FC236}">
+                <a16:creationId xmlns:a16="http://schemas.microsoft.com/office/drawing/2014/main" id="{AD1EFB3B-DFC8-C811-3A38-C59D559C75A5}"/>
+              </a:ext>
+            </a:extLst>
+          </p:cNvPr>
+          <p:cNvSpPr txBox="1"/>
+          <p:nvPr/>
+        </p:nvSpPr>
+        <p:spPr>
+          <a:xfrm>
+            <a:off x="8747766" y="2226921"/>
+            <a:ext cx="2845438" cy="707886"/>
+          </a:xfrm>
+          <a:prstGeom prst="rect">
+            <a:avLst/>
+          </a:prstGeom>
+          <a:noFill/>
+        </p:spPr>
+        <p:txBody>
+          <a:bodyPr wrap="square">
+            <a:spAutoFit/>
+          </a:bodyPr>
+          <a:lstStyle/>
+          <a:p>
+            <a:pPr algn="ctr"/>
+            <a:r>
+              <a:rPr lang="en-US" sz="2000" dirty="0">
+                <a:solidFill>
+                  <a:srgbClr val="0F2343"/>
+                </a:solidFill>
+                <a:latin typeface="Aptos"/>
+                <a:sym typeface="Wingdings" panose="05000000000000000000" pitchFamily="2" charset="2"/>
+              </a:rPr>
+              <a:t>Knapsack capacity:</a:t>
+            </a:r>
+          </a:p>
+          <a:p>
+            <a:pPr algn="ctr"/>
+            <a:r>
+              <a:rPr lang="en-US" sz="2000" dirty="0">
+                <a:solidFill>
+                  <a:srgbClr val="0F2343"/>
+                </a:solidFill>
+                <a:latin typeface="Aptos"/>
+                <a:sym typeface="Wingdings" panose="05000000000000000000" pitchFamily="2" charset="2"/>
+              </a:rPr>
+              <a:t>500</a:t>
+            </a:r>
+            <a:endParaRPr lang="en-US" dirty="0"/>
+          </a:p>
+        </p:txBody>
+      </p:sp>
+      <p:sp>
+        <p:nvSpPr>
+          <p:cNvPr id="32" name="TextBox 31">
+            <a:extLst>
+              <a:ext uri="{FF2B5EF4-FFF2-40B4-BE49-F238E27FC236}">
+                <a16:creationId xmlns:a16="http://schemas.microsoft.com/office/drawing/2014/main" id="{170C59E5-255E-ADE9-E306-26CCB295C306}"/>
+              </a:ext>
+            </a:extLst>
+          </p:cNvPr>
+          <p:cNvSpPr txBox="1"/>
+          <p:nvPr/>
+        </p:nvSpPr>
+        <p:spPr>
+          <a:xfrm>
+            <a:off x="7065258" y="5301373"/>
+            <a:ext cx="3793662" cy="707886"/>
+          </a:xfrm>
+          <a:prstGeom prst="rect">
+            <a:avLst/>
+          </a:prstGeom>
+          <a:noFill/>
+        </p:spPr>
+        <p:txBody>
+          <a:bodyPr wrap="square">
+            <a:spAutoFit/>
+          </a:bodyPr>
+          <a:lstStyle/>
+          <a:p>
+            <a:pPr marL="342900" indent="-342900">
+              <a:buFont typeface="Arial" panose="020B0604020202020204" pitchFamily="34" charset="0"/>
+              <a:buChar char="•"/>
+            </a:pPr>
+            <a:r>
+              <a:rPr lang="en-US" sz="2000" dirty="0">
+                <a:solidFill>
+                  <a:srgbClr val="0F2343"/>
+                </a:solidFill>
+                <a:latin typeface="Aptos"/>
+                <a:sym typeface="Wingdings" panose="05000000000000000000" pitchFamily="2" charset="2"/>
+              </a:rPr>
+              <a:t>Weight used: 500 / 500</a:t>
+            </a:r>
+          </a:p>
+          <a:p>
+            <a:pPr marL="342900" indent="-342900">
+              <a:buFont typeface="Arial" panose="020B0604020202020204" pitchFamily="34" charset="0"/>
+              <a:buChar char="•"/>
+            </a:pPr>
+            <a:r>
+              <a:rPr lang="en-US" sz="2000" dirty="0">
+                <a:solidFill>
+                  <a:srgbClr val="0F2343"/>
+                </a:solidFill>
+                <a:latin typeface="Aptos"/>
+                <a:sym typeface="Wingdings" panose="05000000000000000000" pitchFamily="2" charset="2"/>
+              </a:rPr>
+              <a:t>Total calories: 350</a:t>
+            </a:r>
+            <a:endParaRPr lang="en-US" dirty="0"/>
+          </a:p>
+        </p:txBody>
+      </p:sp>
     </p:spTree>
     <p:extLst>
       <p:ext uri="{BB962C8B-B14F-4D97-AF65-F5344CB8AC3E}">
-        <p14:creationId xmlns:p14="http://schemas.microsoft.com/office/powerpoint/2010/main" val="217879742"/>
+        <p14:creationId xmlns:p14="http://schemas.microsoft.com/office/powerpoint/2010/main" val="3217072918"/>
       </p:ext>
     </p:extLst>
   </p:cSld>
@@ -10232,7 +11536,7 @@
         <p:cNvPr id="1" name="">
           <a:extLst>
             <a:ext uri="{FF2B5EF4-FFF2-40B4-BE49-F238E27FC236}">
-              <a16:creationId xmlns:a16="http://schemas.microsoft.com/office/drawing/2014/main" id="{F0943D2B-3609-E5F2-359E-009AD3775975}"/>
+              <a16:creationId xmlns:a16="http://schemas.microsoft.com/office/drawing/2014/main" id="{C1DBDFD5-51C5-DCB4-122A-E4A92B2D1B2A}"/>
             </a:ext>
           </a:extLst>
         </p:cNvPr>
@@ -10252,7 +11556,7 @@
           <p:cNvPr id="2" name="TextBox 1">
             <a:extLst>
               <a:ext uri="{FF2B5EF4-FFF2-40B4-BE49-F238E27FC236}">
-                <a16:creationId xmlns:a16="http://schemas.microsoft.com/office/drawing/2014/main" id="{8ADACEFF-A6FF-EB27-D151-97B21A72ED1E}"/>
+                <a16:creationId xmlns:a16="http://schemas.microsoft.com/office/drawing/2014/main" id="{92D4AAD1-6AF3-F45E-325F-9FA9D04BE7DF}"/>
               </a:ext>
             </a:extLst>
           </p:cNvPr>
@@ -10262,7 +11566,7 @@
         <p:spPr>
           <a:xfrm>
             <a:off x="365760" y="213360"/>
-            <a:ext cx="11567160" cy="615553"/>
+            <a:ext cx="11826240" cy="615553"/>
           </a:xfrm>
           <a:prstGeom prst="rect">
             <a:avLst/>
@@ -10283,7 +11587,7 @@
                 </a:solidFill>
                 <a:latin typeface="Aptos Display"/>
               </a:rPr>
-              <a:t>Testing – verifying DSS at scale</a:t>
+              <a:t>How does the system look like?</a:t>
             </a:r>
             <a:endParaRPr sz="4000" b="1" i="0" baseline="30000" dirty="0">
               <a:solidFill>
@@ -10299,7 +11603,7 @@
           <p:cNvPr id="3" name="Slide Number Placeholder 2">
             <a:extLst>
               <a:ext uri="{FF2B5EF4-FFF2-40B4-BE49-F238E27FC236}">
-                <a16:creationId xmlns:a16="http://schemas.microsoft.com/office/drawing/2014/main" id="{55BF0EC3-F7ED-334F-C1F6-E5FD0A161BDA}"/>
+                <a16:creationId xmlns:a16="http://schemas.microsoft.com/office/drawing/2014/main" id="{2D55A121-836B-3289-013C-35B8822CC22D}"/>
               </a:ext>
             </a:extLst>
           </p:cNvPr>
@@ -10323,10 +11627,679 @@
           </a:p>
         </p:txBody>
       </p:sp>
+      <p:sp>
+        <p:nvSpPr>
+          <p:cNvPr id="6" name="Arrow: Right 5">
+            <a:extLst>
+              <a:ext uri="{FF2B5EF4-FFF2-40B4-BE49-F238E27FC236}">
+                <a16:creationId xmlns:a16="http://schemas.microsoft.com/office/drawing/2014/main" id="{06214161-5E03-DD37-31AA-129A2B8CD126}"/>
+              </a:ext>
+            </a:extLst>
+          </p:cNvPr>
+          <p:cNvSpPr/>
+          <p:nvPr/>
+        </p:nvSpPr>
+        <p:spPr>
+          <a:xfrm>
+            <a:off x="106680" y="2754630"/>
+            <a:ext cx="11479578" cy="400039"/>
+          </a:xfrm>
+          <a:prstGeom prst="rightArrow">
+            <a:avLst/>
+          </a:prstGeom>
+          <a:solidFill>
+            <a:schemeClr val="tx1"/>
+          </a:solidFill>
+          <a:ln>
+            <a:noFill/>
+          </a:ln>
+        </p:spPr>
+        <p:style>
+          <a:lnRef idx="2">
+            <a:schemeClr val="accent1">
+              <a:shade val="15000"/>
+            </a:schemeClr>
+          </a:lnRef>
+          <a:fillRef idx="1">
+            <a:schemeClr val="accent1"/>
+          </a:fillRef>
+          <a:effectRef idx="0">
+            <a:schemeClr val="accent1"/>
+          </a:effectRef>
+          <a:fontRef idx="minor">
+            <a:schemeClr val="lt1"/>
+          </a:fontRef>
+        </p:style>
+        <p:txBody>
+          <a:bodyPr rtlCol="0" anchor="ctr"/>
+          <a:lstStyle/>
+          <a:p>
+            <a:pPr algn="ctr"/>
+            <a:endParaRPr lang="en-US"/>
+          </a:p>
+        </p:txBody>
+      </p:sp>
+      <p:sp>
+        <p:nvSpPr>
+          <p:cNvPr id="8" name="Rectangle 7">
+            <a:extLst>
+              <a:ext uri="{FF2B5EF4-FFF2-40B4-BE49-F238E27FC236}">
+                <a16:creationId xmlns:a16="http://schemas.microsoft.com/office/drawing/2014/main" id="{380CC933-0BE6-3C0D-4798-D0EC24A2AA95}"/>
+              </a:ext>
+            </a:extLst>
+          </p:cNvPr>
+          <p:cNvSpPr/>
+          <p:nvPr/>
+        </p:nvSpPr>
+        <p:spPr>
+          <a:xfrm>
+            <a:off x="765048" y="1699263"/>
+            <a:ext cx="1645920" cy="2125977"/>
+          </a:xfrm>
+          <a:prstGeom prst="rect">
+            <a:avLst/>
+          </a:prstGeom>
+          <a:solidFill>
+            <a:schemeClr val="bg1">
+              <a:lumMod val="85000"/>
+            </a:schemeClr>
+          </a:solidFill>
+          <a:ln>
+            <a:noFill/>
+          </a:ln>
+          <a:effectLst>
+            <a:outerShdw blurRad="50800" dist="38100" dir="2700000" algn="tl" rotWithShape="0">
+              <a:prstClr val="black">
+                <a:alpha val="40000"/>
+              </a:prstClr>
+            </a:outerShdw>
+          </a:effectLst>
+        </p:spPr>
+        <p:style>
+          <a:lnRef idx="2">
+            <a:schemeClr val="accent1">
+              <a:shade val="15000"/>
+            </a:schemeClr>
+          </a:lnRef>
+          <a:fillRef idx="1">
+            <a:schemeClr val="accent1"/>
+          </a:fillRef>
+          <a:effectRef idx="0">
+            <a:schemeClr val="accent1"/>
+          </a:effectRef>
+          <a:fontRef idx="minor">
+            <a:schemeClr val="lt1"/>
+          </a:fontRef>
+        </p:style>
+        <p:txBody>
+          <a:bodyPr rtlCol="0" anchor="t"/>
+          <a:lstStyle/>
+          <a:p>
+            <a:pPr algn="ctr"/>
+            <a:r>
+              <a:rPr lang="en-US" sz="1600" b="1" dirty="0">
+                <a:solidFill>
+                  <a:schemeClr val="tx1"/>
+                </a:solidFill>
+              </a:rPr>
+              <a:t>Data loading</a:t>
+            </a:r>
+          </a:p>
+          <a:p>
+            <a:pPr algn="ctr"/>
+            <a:endParaRPr lang="en-US" sz="1600" b="1" dirty="0">
+              <a:solidFill>
+                <a:schemeClr val="tx1"/>
+              </a:solidFill>
+            </a:endParaRPr>
+          </a:p>
+          <a:p>
+            <a:pPr marL="171450" indent="-171450">
+              <a:buFont typeface="Arial" panose="020B0604020202020204" pitchFamily="34" charset="0"/>
+              <a:buChar char="•"/>
+            </a:pPr>
+            <a:r>
+              <a:rPr lang="en-US" sz="1200" dirty="0">
+                <a:solidFill>
+                  <a:schemeClr val="tx1"/>
+                </a:solidFill>
+              </a:rPr>
+              <a:t>Reads input data from different sources</a:t>
+            </a:r>
+          </a:p>
+          <a:p>
+            <a:pPr marL="171450" indent="-171450">
+              <a:buFont typeface="Arial" panose="020B0604020202020204" pitchFamily="34" charset="0"/>
+              <a:buChar char="•"/>
+            </a:pPr>
+            <a:endParaRPr lang="en-US" sz="1200" dirty="0">
+              <a:solidFill>
+                <a:schemeClr val="tx1"/>
+              </a:solidFill>
+            </a:endParaRPr>
+          </a:p>
+          <a:p>
+            <a:pPr marL="171450" indent="-171450">
+              <a:buFont typeface="Arial" panose="020B0604020202020204" pitchFamily="34" charset="0"/>
+              <a:buChar char="•"/>
+            </a:pPr>
+            <a:r>
+              <a:rPr lang="en-US" sz="1200" dirty="0">
+                <a:solidFill>
+                  <a:schemeClr val="tx1"/>
+                </a:solidFill>
+              </a:rPr>
+              <a:t>Uses a Data Model to abstract the sources.</a:t>
+            </a:r>
+          </a:p>
+          <a:p>
+            <a:endParaRPr lang="en-US" sz="1200" dirty="0">
+              <a:solidFill>
+                <a:schemeClr val="tx1"/>
+              </a:solidFill>
+            </a:endParaRPr>
+          </a:p>
+        </p:txBody>
+      </p:sp>
+      <p:sp>
+        <p:nvSpPr>
+          <p:cNvPr id="10" name="Rectangle 9">
+            <a:extLst>
+              <a:ext uri="{FF2B5EF4-FFF2-40B4-BE49-F238E27FC236}">
+                <a16:creationId xmlns:a16="http://schemas.microsoft.com/office/drawing/2014/main" id="{1DC1B1C4-97AF-D8E6-A25A-DCB17ED9D775}"/>
+              </a:ext>
+            </a:extLst>
+          </p:cNvPr>
+          <p:cNvSpPr/>
+          <p:nvPr/>
+        </p:nvSpPr>
+        <p:spPr>
+          <a:xfrm>
+            <a:off x="2596134" y="1699263"/>
+            <a:ext cx="1645920" cy="2125977"/>
+          </a:xfrm>
+          <a:prstGeom prst="rect">
+            <a:avLst/>
+          </a:prstGeom>
+          <a:solidFill>
+            <a:schemeClr val="bg1">
+              <a:lumMod val="85000"/>
+            </a:schemeClr>
+          </a:solidFill>
+          <a:ln>
+            <a:noFill/>
+          </a:ln>
+          <a:effectLst>
+            <a:outerShdw blurRad="50800" dist="38100" dir="2700000" algn="tl" rotWithShape="0">
+              <a:prstClr val="black">
+                <a:alpha val="40000"/>
+              </a:prstClr>
+            </a:outerShdw>
+          </a:effectLst>
+        </p:spPr>
+        <p:style>
+          <a:lnRef idx="2">
+            <a:schemeClr val="accent1">
+              <a:shade val="15000"/>
+            </a:schemeClr>
+          </a:lnRef>
+          <a:fillRef idx="1">
+            <a:schemeClr val="accent1"/>
+          </a:fillRef>
+          <a:effectRef idx="0">
+            <a:schemeClr val="accent1"/>
+          </a:effectRef>
+          <a:fontRef idx="minor">
+            <a:schemeClr val="lt1"/>
+          </a:fontRef>
+        </p:style>
+        <p:txBody>
+          <a:bodyPr rtlCol="0" anchor="t"/>
+          <a:lstStyle/>
+          <a:p>
+            <a:pPr algn="ctr"/>
+            <a:r>
+              <a:rPr lang="en-US" sz="1600" b="1" dirty="0">
+                <a:solidFill>
+                  <a:schemeClr val="tx1"/>
+                </a:solidFill>
+              </a:rPr>
+              <a:t>Preprocessing</a:t>
+            </a:r>
+          </a:p>
+          <a:p>
+            <a:pPr algn="ctr"/>
+            <a:endParaRPr lang="en-US" sz="1600" b="1" dirty="0">
+              <a:solidFill>
+                <a:schemeClr val="tx1"/>
+              </a:solidFill>
+            </a:endParaRPr>
+          </a:p>
+          <a:p>
+            <a:pPr marL="171450" indent="-171450">
+              <a:buFont typeface="Arial" panose="020B0604020202020204" pitchFamily="34" charset="0"/>
+              <a:buChar char="•"/>
+            </a:pPr>
+            <a:r>
+              <a:rPr lang="en-US" sz="1200" dirty="0">
+                <a:solidFill>
+                  <a:schemeClr val="tx1"/>
+                </a:solidFill>
+              </a:rPr>
+              <a:t>Validation</a:t>
+            </a:r>
+          </a:p>
+          <a:p>
+            <a:pPr marL="171450" indent="-171450">
+              <a:buFont typeface="Arial" panose="020B0604020202020204" pitchFamily="34" charset="0"/>
+              <a:buChar char="•"/>
+            </a:pPr>
+            <a:endParaRPr lang="en-US" sz="1200" dirty="0">
+              <a:solidFill>
+                <a:schemeClr val="tx1"/>
+              </a:solidFill>
+            </a:endParaRPr>
+          </a:p>
+          <a:p>
+            <a:pPr marL="171450" indent="-171450">
+              <a:buFont typeface="Arial" panose="020B0604020202020204" pitchFamily="34" charset="0"/>
+              <a:buChar char="•"/>
+            </a:pPr>
+            <a:r>
+              <a:rPr lang="en-US" sz="1200" dirty="0">
+                <a:solidFill>
+                  <a:schemeClr val="tx1"/>
+                </a:solidFill>
+              </a:rPr>
+              <a:t>Data cleaning</a:t>
+            </a:r>
+          </a:p>
+          <a:p>
+            <a:pPr marL="171450" indent="-171450">
+              <a:buFont typeface="Arial" panose="020B0604020202020204" pitchFamily="34" charset="0"/>
+              <a:buChar char="•"/>
+            </a:pPr>
+            <a:endParaRPr lang="en-US" sz="1200" dirty="0">
+              <a:solidFill>
+                <a:schemeClr val="tx1"/>
+              </a:solidFill>
+            </a:endParaRPr>
+          </a:p>
+          <a:p>
+            <a:pPr marL="171450" indent="-171450">
+              <a:buFont typeface="Arial" panose="020B0604020202020204" pitchFamily="34" charset="0"/>
+              <a:buChar char="•"/>
+            </a:pPr>
+            <a:r>
+              <a:rPr lang="en-US" sz="1200" dirty="0">
+                <a:solidFill>
+                  <a:schemeClr val="tx1"/>
+                </a:solidFill>
+              </a:rPr>
+              <a:t>Data transformation</a:t>
+            </a:r>
+            <a:endParaRPr lang="en-US" sz="1100" dirty="0">
+              <a:solidFill>
+                <a:schemeClr val="tx1"/>
+              </a:solidFill>
+            </a:endParaRPr>
+          </a:p>
+        </p:txBody>
+      </p:sp>
+      <p:sp>
+        <p:nvSpPr>
+          <p:cNvPr id="12" name="Rectangle 11">
+            <a:extLst>
+              <a:ext uri="{FF2B5EF4-FFF2-40B4-BE49-F238E27FC236}">
+                <a16:creationId xmlns:a16="http://schemas.microsoft.com/office/drawing/2014/main" id="{B7D9D9DE-FA44-C5CC-F989-5DDA716CFE88}"/>
+              </a:ext>
+            </a:extLst>
+          </p:cNvPr>
+          <p:cNvSpPr/>
+          <p:nvPr/>
+        </p:nvSpPr>
+        <p:spPr>
+          <a:xfrm>
+            <a:off x="4427220" y="1699263"/>
+            <a:ext cx="1645920" cy="2125977"/>
+          </a:xfrm>
+          <a:prstGeom prst="rect">
+            <a:avLst/>
+          </a:prstGeom>
+          <a:solidFill>
+            <a:schemeClr val="bg1">
+              <a:lumMod val="85000"/>
+            </a:schemeClr>
+          </a:solidFill>
+          <a:ln>
+            <a:noFill/>
+          </a:ln>
+          <a:effectLst>
+            <a:outerShdw blurRad="50800" dist="38100" dir="2700000" algn="tl" rotWithShape="0">
+              <a:prstClr val="black">
+                <a:alpha val="40000"/>
+              </a:prstClr>
+            </a:outerShdw>
+          </a:effectLst>
+        </p:spPr>
+        <p:style>
+          <a:lnRef idx="2">
+            <a:schemeClr val="accent1">
+              <a:shade val="15000"/>
+            </a:schemeClr>
+          </a:lnRef>
+          <a:fillRef idx="1">
+            <a:schemeClr val="accent1"/>
+          </a:fillRef>
+          <a:effectRef idx="0">
+            <a:schemeClr val="accent1"/>
+          </a:effectRef>
+          <a:fontRef idx="minor">
+            <a:schemeClr val="lt1"/>
+          </a:fontRef>
+        </p:style>
+        <p:txBody>
+          <a:bodyPr rtlCol="0" anchor="t"/>
+          <a:lstStyle/>
+          <a:p>
+            <a:pPr algn="ctr"/>
+            <a:r>
+              <a:rPr lang="en-US" sz="1600" b="1" dirty="0">
+                <a:solidFill>
+                  <a:schemeClr val="tx1"/>
+                </a:solidFill>
+              </a:rPr>
+              <a:t>Optimization</a:t>
+            </a:r>
+          </a:p>
+          <a:p>
+            <a:pPr algn="ctr"/>
+            <a:endParaRPr lang="en-US" sz="1600" b="1" dirty="0">
+              <a:solidFill>
+                <a:schemeClr val="tx1"/>
+              </a:solidFill>
+            </a:endParaRPr>
+          </a:p>
+          <a:p>
+            <a:pPr marL="171450" indent="-171450">
+              <a:buFont typeface="Arial" panose="020B0604020202020204" pitchFamily="34" charset="0"/>
+              <a:buChar char="•"/>
+            </a:pPr>
+            <a:r>
+              <a:rPr lang="en-US" sz="1200" dirty="0">
+                <a:solidFill>
+                  <a:schemeClr val="tx1"/>
+                </a:solidFill>
+              </a:rPr>
+              <a:t>Build</a:t>
+            </a:r>
+          </a:p>
+          <a:p>
+            <a:pPr marL="171450" indent="-171450">
+              <a:buFont typeface="Arial" panose="020B0604020202020204" pitchFamily="34" charset="0"/>
+              <a:buChar char="•"/>
+            </a:pPr>
+            <a:endParaRPr lang="en-US" sz="1200" dirty="0">
+              <a:solidFill>
+                <a:schemeClr val="tx1"/>
+              </a:solidFill>
+            </a:endParaRPr>
+          </a:p>
+          <a:p>
+            <a:pPr marL="171450" indent="-171450">
+              <a:buFont typeface="Arial" panose="020B0604020202020204" pitchFamily="34" charset="0"/>
+              <a:buChar char="•"/>
+            </a:pPr>
+            <a:r>
+              <a:rPr lang="en-US" sz="1200" dirty="0">
+                <a:solidFill>
+                  <a:schemeClr val="tx1"/>
+                </a:solidFill>
+              </a:rPr>
+              <a:t>Solve</a:t>
+            </a:r>
+            <a:endParaRPr lang="en-US" sz="1100" dirty="0">
+              <a:solidFill>
+                <a:schemeClr val="tx1"/>
+              </a:solidFill>
+            </a:endParaRPr>
+          </a:p>
+        </p:txBody>
+      </p:sp>
+      <p:sp>
+        <p:nvSpPr>
+          <p:cNvPr id="14" name="Rectangle 13">
+            <a:extLst>
+              <a:ext uri="{FF2B5EF4-FFF2-40B4-BE49-F238E27FC236}">
+                <a16:creationId xmlns:a16="http://schemas.microsoft.com/office/drawing/2014/main" id="{D8D0CBC5-E09C-3D04-E97A-0687FBCD7A82}"/>
+              </a:ext>
+            </a:extLst>
+          </p:cNvPr>
+          <p:cNvSpPr/>
+          <p:nvPr/>
+        </p:nvSpPr>
+        <p:spPr>
+          <a:xfrm>
+            <a:off x="6258306" y="1699263"/>
+            <a:ext cx="1645920" cy="2125977"/>
+          </a:xfrm>
+          <a:prstGeom prst="rect">
+            <a:avLst/>
+          </a:prstGeom>
+          <a:solidFill>
+            <a:schemeClr val="bg1">
+              <a:lumMod val="85000"/>
+            </a:schemeClr>
+          </a:solidFill>
+          <a:ln>
+            <a:noFill/>
+          </a:ln>
+          <a:effectLst>
+            <a:outerShdw blurRad="50800" dist="38100" dir="2700000" algn="tl" rotWithShape="0">
+              <a:prstClr val="black">
+                <a:alpha val="40000"/>
+              </a:prstClr>
+            </a:outerShdw>
+          </a:effectLst>
+        </p:spPr>
+        <p:style>
+          <a:lnRef idx="2">
+            <a:schemeClr val="accent1">
+              <a:shade val="15000"/>
+            </a:schemeClr>
+          </a:lnRef>
+          <a:fillRef idx="1">
+            <a:schemeClr val="accent1"/>
+          </a:fillRef>
+          <a:effectRef idx="0">
+            <a:schemeClr val="accent1"/>
+          </a:effectRef>
+          <a:fontRef idx="minor">
+            <a:schemeClr val="lt1"/>
+          </a:fontRef>
+        </p:style>
+        <p:txBody>
+          <a:bodyPr rtlCol="0" anchor="t"/>
+          <a:lstStyle/>
+          <a:p>
+            <a:pPr algn="ctr"/>
+            <a:r>
+              <a:rPr lang="en-US" sz="1600" b="1" dirty="0">
+                <a:solidFill>
+                  <a:schemeClr val="tx1"/>
+                </a:solidFill>
+              </a:rPr>
+              <a:t>Postprocessing</a:t>
+            </a:r>
+          </a:p>
+          <a:p>
+            <a:pPr algn="ctr"/>
+            <a:endParaRPr lang="en-US" sz="1600" b="1" dirty="0">
+              <a:solidFill>
+                <a:schemeClr val="tx1"/>
+              </a:solidFill>
+            </a:endParaRPr>
+          </a:p>
+          <a:p>
+            <a:pPr marL="171450" indent="-171450">
+              <a:buFont typeface="Arial" panose="020B0604020202020204" pitchFamily="34" charset="0"/>
+              <a:buChar char="•"/>
+            </a:pPr>
+            <a:r>
+              <a:rPr lang="en-US" sz="1200" dirty="0">
+                <a:solidFill>
+                  <a:schemeClr val="tx1"/>
+                </a:solidFill>
+              </a:rPr>
+              <a:t>Filter solutions to be sent to the user</a:t>
+            </a:r>
+          </a:p>
+          <a:p>
+            <a:pPr marL="171450" indent="-171450">
+              <a:buFont typeface="Arial" panose="020B0604020202020204" pitchFamily="34" charset="0"/>
+              <a:buChar char="•"/>
+            </a:pPr>
+            <a:endParaRPr lang="en-US" sz="1200" dirty="0">
+              <a:solidFill>
+                <a:schemeClr val="tx1"/>
+              </a:solidFill>
+            </a:endParaRPr>
+          </a:p>
+          <a:p>
+            <a:endParaRPr lang="en-US" sz="1200" dirty="0">
+              <a:solidFill>
+                <a:schemeClr val="tx1"/>
+              </a:solidFill>
+            </a:endParaRPr>
+          </a:p>
+          <a:p>
+            <a:pPr marL="171450" indent="-171450">
+              <a:buFont typeface="Arial" panose="020B0604020202020204" pitchFamily="34" charset="0"/>
+              <a:buChar char="•"/>
+            </a:pPr>
+            <a:r>
+              <a:rPr lang="en-US" sz="1200" dirty="0">
+                <a:solidFill>
+                  <a:schemeClr val="tx1"/>
+                </a:solidFill>
+              </a:rPr>
+              <a:t>Transform solution to business representation</a:t>
+            </a:r>
+          </a:p>
+          <a:p>
+            <a:pPr marL="171450" indent="-171450">
+              <a:buFont typeface="Arial" panose="020B0604020202020204" pitchFamily="34" charset="0"/>
+              <a:buChar char="•"/>
+            </a:pPr>
+            <a:endParaRPr lang="en-US" sz="1200" dirty="0">
+              <a:solidFill>
+                <a:schemeClr val="tx1"/>
+              </a:solidFill>
+            </a:endParaRPr>
+          </a:p>
+          <a:p>
+            <a:pPr marL="171450" indent="-171450">
+              <a:buFont typeface="Arial" panose="020B0604020202020204" pitchFamily="34" charset="0"/>
+              <a:buChar char="•"/>
+            </a:pPr>
+            <a:endParaRPr lang="en-US" sz="1100" dirty="0">
+              <a:solidFill>
+                <a:schemeClr val="tx1"/>
+              </a:solidFill>
+            </a:endParaRPr>
+          </a:p>
+        </p:txBody>
+      </p:sp>
+      <p:sp>
+        <p:nvSpPr>
+          <p:cNvPr id="16" name="TextBox 15">
+            <a:extLst>
+              <a:ext uri="{FF2B5EF4-FFF2-40B4-BE49-F238E27FC236}">
+                <a16:creationId xmlns:a16="http://schemas.microsoft.com/office/drawing/2014/main" id="{D1487409-03E7-348C-A7F6-B43CC88A1BA1}"/>
+              </a:ext>
+            </a:extLst>
+          </p:cNvPr>
+          <p:cNvSpPr txBox="1"/>
+          <p:nvPr/>
+        </p:nvSpPr>
+        <p:spPr>
+          <a:xfrm>
+            <a:off x="53957" y="2347829"/>
+            <a:ext cx="660181" cy="461665"/>
+          </a:xfrm>
+          <a:prstGeom prst="rect">
+            <a:avLst/>
+          </a:prstGeom>
+          <a:noFill/>
+        </p:spPr>
+        <p:txBody>
+          <a:bodyPr wrap="none" rtlCol="0">
+            <a:spAutoFit/>
+          </a:bodyPr>
+          <a:lstStyle/>
+          <a:p>
+            <a:pPr algn="ctr"/>
+            <a:r>
+              <a:rPr lang="en-US" sz="1200" dirty="0"/>
+              <a:t>User</a:t>
+            </a:r>
+          </a:p>
+          <a:p>
+            <a:pPr algn="ctr"/>
+            <a:r>
+              <a:rPr lang="en-US" sz="1200" dirty="0"/>
+              <a:t>request</a:t>
+            </a:r>
+          </a:p>
+        </p:txBody>
+      </p:sp>
+      <p:sp>
+        <p:nvSpPr>
+          <p:cNvPr id="20" name="TextBox 19">
+            <a:extLst>
+              <a:ext uri="{FF2B5EF4-FFF2-40B4-BE49-F238E27FC236}">
+                <a16:creationId xmlns:a16="http://schemas.microsoft.com/office/drawing/2014/main" id="{9D782E20-A0DE-5C4A-C349-F555FDBFD96A}"/>
+              </a:ext>
+            </a:extLst>
+          </p:cNvPr>
+          <p:cNvSpPr txBox="1"/>
+          <p:nvPr/>
+        </p:nvSpPr>
+        <p:spPr>
+          <a:xfrm>
+            <a:off x="7904226" y="2284699"/>
+            <a:ext cx="1263551" cy="461665"/>
+          </a:xfrm>
+          <a:prstGeom prst="rect">
+            <a:avLst/>
+          </a:prstGeom>
+          <a:noFill/>
+        </p:spPr>
+        <p:txBody>
+          <a:bodyPr wrap="none" rtlCol="0">
+            <a:spAutoFit/>
+          </a:bodyPr>
+          <a:lstStyle/>
+          <a:p>
+            <a:pPr algn="ctr"/>
+            <a:r>
+              <a:rPr lang="en-US" sz="1200" dirty="0"/>
+              <a:t>Business</a:t>
+            </a:r>
+          </a:p>
+          <a:p>
+            <a:pPr algn="ctr"/>
+            <a:r>
+              <a:rPr lang="en-US" sz="1200" dirty="0"/>
+              <a:t>recommendation</a:t>
+            </a:r>
+          </a:p>
+        </p:txBody>
+      </p:sp>
     </p:spTree>
     <p:extLst>
       <p:ext uri="{BB962C8B-B14F-4D97-AF65-F5344CB8AC3E}">
-        <p14:creationId xmlns:p14="http://schemas.microsoft.com/office/powerpoint/2010/main" val="3217072918"/>
+        <p14:creationId xmlns:p14="http://schemas.microsoft.com/office/powerpoint/2010/main" val="2998349401"/>
       </p:ext>
     </p:extLst>
   </p:cSld>

</xml_diff>